<commit_message>
Two shared gate corrections plus Round 3 fixes for L3. Printed model sentences no longer become typeable fields (L3 loses 12 spurious ones, news-desk-frames 9). A slide may mark an assessed item verbatim, which skips the character cap and keeps the geometric overflow gate; L2's exit item is restored word for word. Title slides no longer print the chip row twice. L3's pair choreography, share-out and write-in space rebuilt against the guide's own exemplars
Co-Authored-By: Claude Opus 5 <noreply@anthropic.com>
Claude-Session: https://claude.ai/code/session_01VWaJFc84eoA3U4f2VjTKjw
</commit_message>
<xml_diff>
--- a/products/ai-agent-intern/dist/Lead Your AI Squad - Slides.pptx
+++ b/products/ai-agent-intern/dist/Lead Your AI Squad - Slides.pptx
@@ -2073,204 +2073,6 @@
           </a:p>
         </p:txBody>
       </p:sp>
-      <p:sp>
-        <p:nvSpPr>
-          <p:cNvPr id="9" name="Shape 5"/>
-          <p:cNvSpPr/>
-          <p:nvPr/>
-        </p:nvSpPr>
-        <p:spPr>
-          <a:xfrm>
-            <a:off x="502920" y="3977640"/>
-            <a:ext cx="1097280" cy="310896"/>
-          </a:xfrm>
-          <a:prstGeom prst="roundRect">
-            <a:avLst>
-              <a:gd name="adj" fmla="val 50000"/>
-            </a:avLst>
-          </a:prstGeom>
-          <a:solidFill>
-            <a:srgbClr val="14141F"/>
-          </a:solidFill>
-          <a:ln w="15875">
-            <a:solidFill>
-              <a:srgbClr val="FFB020"/>
-            </a:solidFill>
-            <a:prstDash val="solid"/>
-          </a:ln>
-        </p:spPr>
-      </p:sp>
-      <p:sp>
-        <p:nvSpPr>
-          <p:cNvPr id="10" name="Text 6"/>
-          <p:cNvSpPr txBox="1"/>
-          <p:nvPr/>
-        </p:nvSpPr>
-        <p:spPr>
-          <a:xfrm>
-            <a:off x="502920" y="3977640"/>
-            <a:ext cx="1097280" cy="310896"/>
-          </a:xfrm>
-          <a:prstGeom prst="rect">
-            <a:avLst/>
-          </a:prstGeom>
-          <a:noFill/>
-          <a:ln/>
-        </p:spPr>
-        <p:txBody>
-          <a:bodyPr wrap="square" lIns="0" tIns="0" rIns="0" bIns="0" rtlCol="0" anchor="ctr"/>
-          <a:lstStyle/>
-          <a:p>
-            <a:pPr algn="ctr" indent="0" marL="0">
-              <a:buNone/>
-            </a:pPr>
-            <a:r>
-              <a:rPr lang="en-US" sz="1000" b="1" dirty="0">
-                <a:solidFill>
-                  <a:srgbClr val="FFB020"/>
-                </a:solidFill>
-                <a:latin typeface="Arial" pitchFamily="34" charset="0"/>
-                <a:ea typeface="Arial" pitchFamily="34" charset="-122"/>
-                <a:cs typeface="Arial" pitchFamily="34" charset="-120"/>
-              </a:rPr>
-              <a:t>Grades 6–8</a:t>
-            </a:r>
-            <a:endParaRPr lang="en-US" sz="1000" dirty="0"/>
-          </a:p>
-        </p:txBody>
-      </p:sp>
-      <p:sp>
-        <p:nvSpPr>
-          <p:cNvPr id="11" name="Shape 7"/>
-          <p:cNvSpPr/>
-          <p:nvPr/>
-        </p:nvSpPr>
-        <p:spPr>
-          <a:xfrm>
-            <a:off x="1737360" y="3977640"/>
-            <a:ext cx="1330452" cy="310896"/>
-          </a:xfrm>
-          <a:prstGeom prst="roundRect">
-            <a:avLst>
-              <a:gd name="adj" fmla="val 50000"/>
-            </a:avLst>
-          </a:prstGeom>
-          <a:solidFill>
-            <a:srgbClr val="14141F"/>
-          </a:solidFill>
-          <a:ln w="15875">
-            <a:solidFill>
-              <a:srgbClr val="FFB020"/>
-            </a:solidFill>
-            <a:prstDash val="solid"/>
-          </a:ln>
-        </p:spPr>
-      </p:sp>
-      <p:sp>
-        <p:nvSpPr>
-          <p:cNvPr id="12" name="Text 8"/>
-          <p:cNvSpPr txBox="1"/>
-          <p:nvPr/>
-        </p:nvSpPr>
-        <p:spPr>
-          <a:xfrm>
-            <a:off x="1737360" y="3977640"/>
-            <a:ext cx="1330452" cy="310896"/>
-          </a:xfrm>
-          <a:prstGeom prst="rect">
-            <a:avLst/>
-          </a:prstGeom>
-          <a:noFill/>
-          <a:ln/>
-        </p:spPr>
-        <p:txBody>
-          <a:bodyPr wrap="square" lIns="0" tIns="0" rIns="0" bIns="0" rtlCol="0" anchor="ctr"/>
-          <a:lstStyle/>
-          <a:p>
-            <a:pPr algn="ctr" indent="0" marL="0">
-              <a:buNone/>
-            </a:pPr>
-            <a:r>
-              <a:rPr lang="en-US" sz="1000" b="1" dirty="0">
-                <a:solidFill>
-                  <a:srgbClr val="FFB020"/>
-                </a:solidFill>
-                <a:latin typeface="Arial" pitchFamily="34" charset="0"/>
-                <a:ea typeface="Arial" pitchFamily="34" charset="-122"/>
-                <a:cs typeface="Arial" pitchFamily="34" charset="-120"/>
-              </a:rPr>
-              <a:t>45-min lesson</a:t>
-            </a:r>
-            <a:endParaRPr lang="en-US" sz="1000" dirty="0"/>
-          </a:p>
-        </p:txBody>
-      </p:sp>
-      <p:sp>
-        <p:nvSpPr>
-          <p:cNvPr id="13" name="Shape 9"/>
-          <p:cNvSpPr/>
-          <p:nvPr/>
-        </p:nvSpPr>
-        <p:spPr>
-          <a:xfrm>
-            <a:off x="3204972" y="3977640"/>
-            <a:ext cx="2418588" cy="310896"/>
-          </a:xfrm>
-          <a:prstGeom prst="roundRect">
-            <a:avLst>
-              <a:gd name="adj" fmla="val 50000"/>
-            </a:avLst>
-          </a:prstGeom>
-          <a:solidFill>
-            <a:srgbClr val="14141F"/>
-          </a:solidFill>
-          <a:ln w="15875">
-            <a:solidFill>
-              <a:srgbClr val="FFB020"/>
-            </a:solidFill>
-            <a:prstDash val="solid"/>
-          </a:ln>
-        </p:spPr>
-      </p:sp>
-      <p:sp>
-        <p:nvSpPr>
-          <p:cNvPr id="14" name="Text 10"/>
-          <p:cNvSpPr txBox="1"/>
-          <p:nvPr/>
-        </p:nvSpPr>
-        <p:spPr>
-          <a:xfrm>
-            <a:off x="3204972" y="3977640"/>
-            <a:ext cx="2418588" cy="310896"/>
-          </a:xfrm>
-          <a:prstGeom prst="rect">
-            <a:avLst/>
-          </a:prstGeom>
-          <a:noFill/>
-          <a:ln/>
-        </p:spPr>
-        <p:txBody>
-          <a:bodyPr wrap="square" lIns="0" tIns="0" rIns="0" bIns="0" rtlCol="0" anchor="ctr"/>
-          <a:lstStyle/>
-          <a:p>
-            <a:pPr algn="ctr" indent="0" marL="0">
-              <a:buNone/>
-            </a:pPr>
-            <a:r>
-              <a:rPr lang="en-US" sz="1000" b="1" dirty="0">
-                <a:solidFill>
-                  <a:srgbClr val="FFB020"/>
-                </a:solidFill>
-                <a:latin typeface="Arial" pitchFamily="34" charset="0"/>
-                <a:ea typeface="Arial" pitchFamily="34" charset="-122"/>
-                <a:cs typeface="Arial" pitchFamily="34" charset="-120"/>
-              </a:rPr>
-              <a:t>No prep · No devices needed</a:t>
-            </a:r>
-            <a:endParaRPr lang="en-US" sz="1000" dirty="0"/>
-          </a:p>
-        </p:txBody>
-      </p:sp>
     </p:spTree>
   </p:cSld>
   <p:clrMapOvr>

</xml_diff>

<commit_message>
Round 3 fixes for L6: the rotation is now stated physically (the Scout sits on the Planner's left, every paper moves one seat to its owner's left) so it traces correctly against the product's own filled key; a return step hands the paper back and reads the FIX line to its owner; write-in cells carry real ruled lines sized to the guide's exemplars, which takes the worksheet to 3 pages and every count with it; the agent claim is hedged everywhere; role and check-one rows became radio groups
Co-Authored-By: Claude Opus 5 <noreply@anthropic.com>
Claude-Session: https://claude.ai/code/session_01VWaJFc84eoA3U4f2VjTKjw
</commit_message>
<xml_diff>
--- a/products/ai-agent-intern/dist/Lead Your AI Squad - Slides.pptx
+++ b/products/ai-agent-intern/dist/Lead Your AI Squad - Slides.pptx
@@ -513,7 +513,7 @@
           <a:p>
             <a:r>
               <a:rPr lang="en-US" dirty="0"/>
-              <a:t>Open on this slide while students settle. Worksheet: Run the Quest, one per student (2 pages), plus one sheet of scrap paper per student for squad outputs. Plan teams of 3 (30 students = 10 teams; remainder rule is in the Activity notes). Fully unplugged by design. Deck follows the lesson plan block for block; minute chips top-right match it.</a:t>
+              <a:t>Open on this slide while students settle. Worksheet: Run the Quest, one per student (3 pages), plus one sheet of scrap paper per student for squad outputs. Plan teams of 3 (30 students = 10 teams; remainder rule is in the Activity notes). Fully unplugged by design. Deck follows the lesson plan block for block; minute chips top-right match it.</a:t>
             </a:r>
             <a:endParaRPr lang="en-US" dirty="0"/>
           </a:p>
@@ -601,7 +601,7 @@
           <a:p>
             <a:r>
               <a:rPr lang="en-US" dirty="0"/>
-              <a:t>Leave this up during Leader review. "Read it like your name is on it — because it is." KEY — a filled CHECK row (Lucia reviewing DeShawn's planner list): ACCURACY — SHIP IT: "Steps 1–4 use Friday, gym, 6–8 pm straight off the card." TASTE — RUN IT BACK: "Step 3 says 'write the pitch' but never says to 6th graders — it could be for anybody." DONE-NESS — SHIP IT: "All four card parts are covered, and the NOT ON THE CARD flag is a plus." Exemplar note — KEEP: "Every step has a time guess and all four card parts are covered." FIX: "Step 3 needs the words 'for 6th graders' — the card names the audience and the plan dropped it." WHAT IF a leader turns harsh: KEEP before FIX, read aloud. TRANSITION: "Loot checked. Last quest: one for your own life. Bottom of page 2."</a:t>
+              <a:t>Leave this up during Leader review. "Read it like your name is on it — because it is." KEY — a filled CHECK row (Lucia reviewing DeShawn's planner list): ACCURACY — SHIP IT: "Steps 1–4 use Friday, gym, 6–8 pm straight off the card." TASTE — RUN IT BACK: "Step 3 says 'write the pitch' but never says to 6th graders — it could be for anybody." DONE-NESS — SHIP IT: "All four card parts are covered, and the NOT ON THE CARD flag is a plus." Exemplar note — KEEP: "Every step has a time guess and all four card parts are covered." FIX: "Step 3 needs the words 'for 6th graders' — the card names the audience and the plan dropped it." WHAT IF a leader turns harsh: KEEP before FIX, read aloud. Last 60 seconds of the block: hand the paper back and read your FIX line to its owner. TRANSITION: "Loot checked. Last quest: one for your own life. Page 3."</a:t>
             </a:r>
             <a:endParaRPr lang="en-US" dirty="0"/>
           </a:p>
@@ -689,7 +689,7 @@
           <a:p>
             <a:r>
               <a:rPr lang="en-US" dirty="0"/>
-              <a:t>Worksheet p.2, solo, 6 minutes. Collect. KEY — #1 exemplar (study plan): GOAL: pass Friday's fractions quiz with at least a B. WHAT WE KNOW: 7th grade math; I have the review sheet and 30 minutes a night, Monday to Thursday. RULES OF THE RUN: only fractions with different denominators, no calculators, nothing due before Wednesday. DONE LOOKS LIKE: a four-night plan, 5 practice problems a night with answers on a separate line. Test: could a stranger do it tomorrow from the card alone? Scoring: Proficient = all four parts labeled and specific; Developing = parts present but vague ("make it good," "soon"); Beginning = a wish, not a quest card ("help me with math"). #2: any role with a reason tied to the task (scout for a fact-heavy flyer; planner for a schedule) — the reason is what scores. #3: any check with something real to look for ("accuracy — the quiz date"; "done-ness — did it give all four nights?"). WHAT IF a student writes a wish: "Which part is missing? Add the one that would stop a stranger from guessing." Sentence starters for support: Teacher Guide, p.2.</a:t>
+              <a:t>Worksheet p.3, solo, 6 minutes. Collect. KEY — #1 exemplar (study plan): GOAL: pass Friday's fractions quiz with at least a B. WHAT WE KNOW: 7th grade math; I have the review sheet and 30 minutes a night, Monday to Thursday. RULES OF THE RUN: only fractions with different denominators, no calculators, nothing due before Wednesday. DONE LOOKS LIKE: a four-night plan, 5 practice problems a night with answers on a separate line. Test: could a stranger do it tomorrow from the card alone? Scoring: Proficient = all four parts labeled and specific; Developing = parts present but vague ("make it good," "soon"); Beginning = a wish, not a quest card ("help me with math"). #2: any role with a reason tied to the task (scout for a fact-heavy flyer; planner for a schedule) — the reason is what scores. #3: any check with something real to look for ("accuracy — the quiz date"; "done-ness — did it give all four nights?"). WHAT IF a student writes a wish: "Which part is missing? Add the one that would stop a stranger from guessing." Sentence starters for support: Teacher Guide, p.1.</a:t>
             </a:r>
             <a:endParaRPr lang="en-US" dirty="0"/>
           </a:p>
@@ -953,7 +953,7 @@
           <a:p>
             <a:r>
               <a:rPr lang="en-US" dirty="0"/>
-              <a:t>Take two or three answers. Bridge: "An AI agent doesn't just answer — it does a whole job in steps: makes a plan, looks things up, uses tools, and hands you a finished thing. Where your quest card is vague, it fills the gap with its best guess and keeps going. That's why the leader checks. You'll never out-work it. You CAN out-lead it." TRANSITION: "Today you learn the leader's loop: quest card, roles, check the loot — then ship it or run it back. Four parts. Board."</a:t>
+              <a:t>Take two or three answers. Bridge: "An AI agent doesn't just answer — it does a whole job in steps: makes a plan, looks things up, uses tools, and hands you a finished thing. Where your quest card is vague, it usually fills the gap with a guess and keeps going. Some tools stop and ask instead. That's why the leader checks. You'll never out-work it. You CAN out-lead it." TRANSITION: "Today you learn the leader's loop: quest card, roles, check the loot — then ship it or run it back. Four parts. Board."</a:t>
             </a:r>
             <a:endParaRPr lang="en-US" dirty="0"/>
           </a:p>
@@ -1393,7 +1393,7 @@
           <a:p>
             <a:r>
               <a:rPr lang="en-US" dirty="0"/>
-              <a:t>KEY — what good output looks like (Game Night card): PLANNER: 1. Pick the games and TV set-up (5 min) 2. Write the flyer title and the when/where line (5 min) 3. ★ Add a 40-word pitch (10 min) 4. Count words, check the rules (3 min) 5. NOT ON THE CARD: who photocopies it, and how many? (Minutes 4–8 add the time guesses and the star.) SCOUT: Friday ✓ (on the card) · gym ✓ (on the card) · 6–8 pm ✓ (on the card) · both TVs actually work? ? (ask whoever runs the gym) · how many 6th graders there are ? (the front office). CRITIC: minutes 0–4, what the audience cares about: which games, and whether friends are going. Upgrades: (1) Put the TVs and the games in the title — 6th graders come for the games, not the date. (2) Cut the 40 words to 25; nobody reads a wall of text on a wall. (3) Add one line for parents: pick-up is at 8. Paper logic: papers never move mid-round; at the 4-minute call the Critic reads the Planner's list over their shoulder. Seat Planner → Scout → Critic so the swap (own paper, one seat left) lands each paper on a fresh reader. Coaching: the planner's NOT ON THE CARD flags are gold — they're the next card's fixes. A scout's fact with no "how we know" is a guess wearing a costume. Vague praise from a critic doesn't count. TRANSITION: "Page 1. Pick your quest. One card per team — everyone copies it. Six minutes."</a:t>
+              <a:t>KEY — what good output looks like (Game Night card): PLANNER: 1. Pick the games and TV set-up (5 min) 2. Write the flyer title and the when/where line (5 min) 3. ★ Add a 40-word pitch (10 min) 4. Count words, check the rules (3 min) 5. NOT ON THE CARD: who photocopies it, and how many? (Minutes 4–8 add the time guesses and the star.) SCOUT: Friday ✓ (on the card) · gym ✓ (on the card) · 6–8 pm ✓ (on the card) · both TVs actually work? ? (ask whoever runs the gym) · how many 6th graders there are ? (the front office). CRITIC: minutes 0–4, what the audience cares about: which games, and whether friends are going. Upgrades: (1) Put the TVs and the games in the title — 6th graders come for the games, not the date. (2) Cut the 40 words to 25; nobody reads a wall of text on a wall. (3) Add one line for parents: pick-up is at 8. Paper logic: papers never move mid-round; at the 4-minute call the Critic reads the Planner's list over their shoulder. ROTATION: Sit in a triangle. The Scout sits on the Planner's left; the Critic sits on the Scout's left. Every paper moves one seat to its owner's left — the Planner's plan goes to the Scout, the Scout's questions go to the Critic, the Critic's list goes to the Planner. Coaching: the planner's NOT ON THE CARD flags are gold — they're the next card's fixes. A scout's fact with no "how we know" is a guess wearing a costume. Vague praise from a critic doesn't count. TRANSITION: "Page 1. Pick your quest. ONE card per team: the card-holder writes all four parts, everyone copies GOAL and DONE LOOKS LIKE. Eight minutes."</a:t>
             </a:r>
             <a:endParaRPr lang="en-US" dirty="0"/>
           </a:p>
@@ -1481,7 +1481,7 @@
           <a:p>
             <a:r>
               <a:rPr lang="en-US" dirty="0"/>
-              <a:t>WRITE THE CARD — WHAT IF a team stalls on GOAL: "What would make you say we won?" TRANSITION at 6 min: "Cards done. Sit Planner → Scout → Critic. Now switch: for 8 minutes YOU play an AI agent. Take a role card. Silence starts now." SQUAD WORKS — in Sana's squad: DeShawn plans, Lucia scouts, Sana critiques. Papers never move mid-round. At the 4-minute call: "Critics, read your Planner's list over their shoulder — 3 upgrades. Planners, add a time guess to every step and star the one most likely to go wrong." Enforce the silence — when a party member asks a question mid-round, answer: "It's not on the card." The frustration is the point. Don't rescue a weak card; the review makes the failure visible and fixable. WHAT IF the class doesn't divide by 3: team of 4 = two critics (both read the plan); team of 2 = drop the critic, the leader does the taste check. 30 students = 10 teams. TRANSITION at 8 min: "Time. Every party member passes their OWN paper one seat left. You're the leader again — page 2." LEADER REVIEW — with the Planner → Scout → Critic seating, Lucia reviews DeShawn's plan, Sana reviews Lucia's facts, DeShawn reviews Sana's upgrades: the Critic never re-reviews the Planner's list. WHAT IF a leader turns harsh: KEEP comes before FIX, and they read the note aloud to their party member. Next slide stays up during the review.</a:t>
+              <a:t>WRITE THE CARD — WHAT IF a team stalls on GOAL: "What would make you say we won?" TRANSITION at 8 min: "Cards done. For 8 minutes YOU play an AI agent. Take a role card. Silence starts now." SQUAD WORKS — in Sana's squad: DeShawn plans, Lucia scouts, Sana critiques. Papers never move mid-round. At the 4-minute call: "Critics, read your Planner's list over their shoulder — 3 upgrades. Planners, add a time guess to every step and star the one most likely to go wrong." Enforce the silence — when a party member asks a question mid-round, answer: "It's not on the card." The frustration is the point. Don't rescue a weak card; the review makes the failure visible and fixable. WHAT IF the class doesn't divide by 3: team of 4 = two critics (both read the plan); team of 2 = drop the critic, the leader does the taste check. 30 students = 10 teams. TRANSITION at the swap: "Time. Sit in a triangle. The Scout sits on the Planner's left; the Critic sits on the Scout's left. Every paper moves one seat to its owner's left — the Planner's plan goes to the Scout, the Scout's questions go to the Critic, the Critic's list goes to the Planner. Keep your worksheet — you're the leader again, page 2." LEADER REVIEW — with that seating, Lucia (Scout) reviews DeShawn's (Planner) plan, Sana (Critic) reviews Lucia's facts, DeShawn reviews Sana's upgrades: the Critic never re-reviews the Planner's list. Each leader quotes ONE line of evidence for the row they mark RUN IT BACK, plus KEEP and FIX; in the last 60 seconds they hand the paper back and read the FIX line to its owner. WHAT IF a leader turns harsh: KEEP comes before FIX, and they read the note aloud to their party member. Next slide stays up during the review.</a:t>
             </a:r>
             <a:endParaRPr lang="en-US" dirty="0"/>
           </a:p>
@@ -2059,7 +2059,7 @@
               <a:buNone/>
             </a:pPr>
             <a:r>
-              <a:rPr lang="en-US" sz="1200" dirty="0">
+              <a:rPr lang="en-US" sz="1400" dirty="0">
                 <a:solidFill>
                   <a:srgbClr val="E8E8F5"/>
                 </a:solidFill>
@@ -2067,9 +2067,9 @@
                 <a:ea typeface="Arial" pitchFamily="34" charset="-122"/>
                 <a:cs typeface="Arial" pitchFamily="34" charset="-120"/>
               </a:rPr>
-              <a:t>An AI agent does a whole job, step by step, on its own — and if your card leaves something out, the agent just guesses and keeps going. Party leaders don't redo the party's work: they write the quest card, hand out the roles, and check the loot.</a:t>
-            </a:r>
-            <a:endParaRPr lang="en-US" sz="1200" dirty="0"/>
+              <a:t>An AI agent does a whole job, step by step, on its own — and if your card leaves something out, the agent usually fills the gap with a guess and keeps going.</a:t>
+            </a:r>
+            <a:endParaRPr lang="en-US" sz="1400" dirty="0"/>
           </a:p>
         </p:txBody>
       </p:sp>
@@ -2601,7 +2601,7 @@
                 <a:ea typeface="Arial" pitchFamily="34" charset="-122"/>
                 <a:cs typeface="Arial" pitchFamily="34" charset="-120"/>
               </a:rPr>
-              <a:t>1.  Pick one real task in YOUR life to hand an AI agent this week — a study plan, a chore list, a team flyer.</a:t>
+              <a:t>1.  Write a quest card for one real task in YOUR life this week (a study plan, a chore list, a team flyer): GOAL · WHAT WE KNOW · RULES OF THE RUN · DONE LOOKS LIKE.</a:t>
             </a:r>
             <a:endParaRPr lang="en-US" sz="1800" dirty="0"/>
           </a:p>
@@ -2622,7 +2622,7 @@
                 <a:ea typeface="Arial" pitchFamily="34" charset="-122"/>
                 <a:cs typeface="Arial" pitchFamily="34" charset="-120"/>
               </a:rPr>
-              <a:t>     Write the full quest card: GOAL · WHAT WE KNOW · RULES OF THE RUN · DONE LOOKS LIKE.</a:t>
+              <a:t>2.  Which role gets it first? Check one, then write why: Planner · Scout · Critic</a:t>
             </a:r>
             <a:endParaRPr lang="en-US" sz="1800" dirty="0"/>
           </a:p>
@@ -2643,28 +2643,7 @@
                 <a:ea typeface="Arial" pitchFamily="34" charset="-122"/>
                 <a:cs typeface="Arial" pitchFamily="34" charset="-120"/>
               </a:rPr>
-              <a:t>2.  Which role would you hand it to first — planner, scout or critic? Check one and say why.</a:t>
-            </a:r>
-            <a:endParaRPr lang="en-US" sz="1800" dirty="0"/>
-          </a:p>
-          <a:p>
-            <a:pPr marL="342900" indent="-342900">
-              <a:spcAft>
-                <a:spcPts val="800"/>
-              </a:spcAft>
-              <a:buSzPct val="100000"/>
-              <a:buChar char="■"/>
-            </a:pPr>
-            <a:r>
-              <a:rPr lang="en-US" sz="1800" dirty="0">
-                <a:solidFill>
-                  <a:srgbClr val="E8E8F5"/>
-                </a:solidFill>
-                <a:latin typeface="Arial" pitchFamily="34" charset="0"/>
-                <a:ea typeface="Arial" pitchFamily="34" charset="-122"/>
-                <a:cs typeface="Arial" pitchFamily="34" charset="-120"/>
-              </a:rPr>
-              <a:t>3.  Which check would it most likely fail — accuracy, taste or done-ness? Check one; say what you'd look for.</a:t>
+              <a:t>3.  Which check would it most likely fail? Check one, then write what you'd look for: Accuracy · Taste · Done-ness</a:t>
             </a:r>
             <a:endParaRPr lang="en-US" sz="1800" dirty="0"/>
           </a:p>
@@ -3053,7 +3032,7 @@
                 <a:ea typeface="Arial" pitchFamily="34" charset="-122"/>
                 <a:cs typeface="Arial" pitchFamily="34" charset="-120"/>
               </a:rPr>
-              <a:t>7 MIN</a:t>
+              <a:t>6 MIN</a:t>
             </a:r>
             <a:endParaRPr lang="en-US" sz="1000" dirty="0"/>
           </a:p>
@@ -3532,7 +3511,7 @@
         <p:spPr>
           <a:xfrm>
             <a:off x="1737360" y="1188720"/>
-            <a:ext cx="6903720" cy="1873377"/>
+            <a:ext cx="6903720" cy="3406140"/>
           </a:xfrm>
           <a:prstGeom prst="rect">
             <a:avLst/>
@@ -3559,45 +3538,6 @@
               <a:t>The party member's — or the orders?</a:t>
             </a:r>
             <a:endParaRPr lang="en-US" sz="3000" dirty="0"/>
-          </a:p>
-        </p:txBody>
-      </p:sp>
-      <p:sp>
-        <p:nvSpPr>
-          <p:cNvPr id="8" name="Text 5"/>
-          <p:cNvSpPr txBox="1"/>
-          <p:nvPr/>
-        </p:nvSpPr>
-        <p:spPr>
-          <a:xfrm>
-            <a:off x="1737360" y="3199257"/>
-            <a:ext cx="6903720" cy="1395603"/>
-          </a:xfrm>
-          <a:prstGeom prst="rect">
-            <a:avLst/>
-          </a:prstGeom>
-          <a:noFill/>
-          <a:ln/>
-        </p:spPr>
-        <p:txBody>
-          <a:bodyPr wrap="square" lIns="0" tIns="0" rIns="0" bIns="0" rtlCol="0" anchor="t"/>
-          <a:lstStyle/>
-          <a:p>
-            <a:pPr indent="0" marL="0">
-              <a:buNone/>
-            </a:pPr>
-            <a:r>
-              <a:rPr lang="en-US" sz="1600" dirty="0">
-                <a:solidFill>
-                  <a:srgbClr val="A9A9C4"/>
-                </a:solidFill>
-                <a:latin typeface="Arial" pitchFamily="34" charset="0"/>
-                <a:ea typeface="Arial" pitchFamily="34" charset="-122"/>
-                <a:cs typeface="Arial" pitchFamily="34" charset="-120"/>
-              </a:rPr>
-              <a:t>An AI agent does a whole job, step by step, on its own — and if your card leaves something out, the agent just guesses and keeps going.</a:t>
-            </a:r>
-            <a:endParaRPr lang="en-US" sz="1600" dirty="0"/>
           </a:p>
         </p:txBody>
       </p:sp>
@@ -3771,7 +3711,7 @@
                 <a:ea typeface="Arial" pitchFamily="34" charset="-122"/>
                 <a:cs typeface="Arial" pitchFamily="34" charset="-120"/>
               </a:rPr>
-              <a:t>10 MIN</a:t>
+              <a:t>9 MIN</a:t>
             </a:r>
             <a:endParaRPr lang="en-US" sz="1000" dirty="0"/>
           </a:p>
@@ -3979,7 +3919,7 @@
                 <a:ea typeface="Arial" pitchFamily="34" charset="-122"/>
                 <a:cs typeface="Arial" pitchFamily="34" charset="-120"/>
               </a:rPr>
-              <a:t>Write the job down, all four parts. Leave something out and the party guesses — wrong.</a:t>
+              <a:t>Leave something out and the party guesses — and you won't know whether it guessed right.</a:t>
             </a:r>
             <a:endParaRPr lang="en-US" sz="1400" dirty="0"/>
           </a:p>
@@ -6681,7 +6621,7 @@
                 <a:ea typeface="Arial" pitchFamily="34" charset="-122"/>
                 <a:cs typeface="Arial" pitchFamily="34" charset="-120"/>
               </a:rPr>
-              <a:t>Minutes 0–4: a numbered step list. Card silent? Write "NOT ON THE CARD." Minutes 4–8: a time guess per step; star the riskiest.</a:t>
+              <a:t>0–4 min: a numbered step list. Card silent? Write "NOT ON THE CARD." 4–8 min: a time guess per step; star the riskiest.</a:t>
             </a:r>
             <a:endParaRPr lang="en-US" sz="1400" dirty="0"/>
           </a:p>
@@ -6850,7 +6790,7 @@
                 <a:ea typeface="Arial" pitchFamily="34" charset="-122"/>
                 <a:cs typeface="Arial" pitchFamily="34" charset="-120"/>
               </a:rPr>
-              <a:t>List every fact the quest needs. Mark each ✓ (we know it for sure — say how) or ? (needs checking — say where).</a:t>
+              <a:t>0–4 min: list every fact the quest needs; mark each ✓ (say how) or ? (say where). 4–8 min: turn every ? into the one question you'd ask.</a:t>
             </a:r>
             <a:endParaRPr lang="en-US" sz="1400" dirty="0"/>
           </a:p>
@@ -7019,7 +6959,7 @@
                 <a:ea typeface="Arial" pitchFamily="34" charset="-122"/>
                 <a:cs typeface="Arial" pitchFamily="34" charset="-120"/>
               </a:rPr>
-              <a:t>0–4 min: write 2 things the audience on the card cares about. When the teacher calls 4 min, read the Planner's list; write 3 upgrades.</a:t>
+              <a:t>0–4 min: write 2 things the audience on the card cares about. 4–8 min: read the Planner's list; write 3 upgrades.</a:t>
             </a:r>
             <a:endParaRPr lang="en-US" sz="1400" dirty="0"/>
           </a:p>
@@ -7195,7 +7135,7 @@
                 <a:ea typeface="Arial" pitchFamily="34" charset="-122"/>
                 <a:cs typeface="Arial" pitchFamily="34" charset="-120"/>
               </a:rPr>
-              <a:t>22 MIN</a:t>
+              <a:t>24 MIN</a:t>
             </a:r>
             <a:endParaRPr lang="en-US" sz="1000" dirty="0"/>
           </a:p>
@@ -7337,7 +7277,7 @@
                 <a:ea typeface="Arial" pitchFamily="34" charset="-122"/>
                 <a:cs typeface="Arial" pitchFamily="34" charset="-120"/>
               </a:rPr>
-              <a:t>Write the quest card   ·   6 min</a:t>
+              <a:t>Write the quest card   ·   8 min</a:t>
             </a:r>
             <a:endParaRPr lang="en-US" sz="1500" dirty="0"/>
           </a:p>
@@ -7376,7 +7316,7 @@
                 <a:ea typeface="Arial" pitchFamily="34" charset="-122"/>
                 <a:cs typeface="Arial" pitchFamily="34" charset="-120"/>
               </a:rPr>
-              <a:t>Teams of 3. Pick a quest — Game Night page or class magazine issue #1 — and write ONE card, all four parts. Everyone copies it.</a:t>
+              <a:t>Teams of 3. Pick a quest. ONE card per team: the card-holder writes all four parts; the others copy GOAL and DONE LOOKS LIKE.</a:t>
             </a:r>
             <a:endParaRPr lang="en-US" sz="1300" dirty="0"/>
           </a:p>
@@ -7479,7 +7419,7 @@
                 <a:ea typeface="Arial" pitchFamily="34" charset="-122"/>
                 <a:cs typeface="Arial" pitchFamily="34" charset="-120"/>
               </a:rPr>
-              <a:t>Party works   ·   8 min</a:t>
+              <a:t>Squad works   ·   8 min</a:t>
             </a:r>
             <a:endParaRPr lang="en-US" sz="1500" dirty="0"/>
           </a:p>
@@ -7660,7 +7600,7 @@
                 <a:ea typeface="Arial" pitchFamily="34" charset="-122"/>
                 <a:cs typeface="Arial" pitchFamily="34" charset="-120"/>
               </a:rPr>
-              <a:t>Pass that blank sheet one seat left; keep this worksheet — you're the leader again. CHECK rubric: SHIP IT or RUN IT BACK per row, then the note.</a:t>
+              <a:t>Every paper moves one seat to its owner's left. CHECK rubric: SHIP IT or RUN IT BACK per row, then the note — and hand the paper back.</a:t>
             </a:r>
             <a:endParaRPr lang="en-US" sz="1300" dirty="0"/>
           </a:p>

</xml_diff>

<commit_message>
L6 rewritten on Opus 5.5 and kept after a 17-1 blind A/B: each team now gets one planted invented fact, so the leader's check has something real to catch, and slide 9 says what the worksheet says. 'DJ' is no longer banned line-wide: it was retired to catch a leftover crate analogy in L2, stays banned there, and elsewhere carries the store's voice
Co-Authored-By: Claude Opus 5.5 <noreply@anthropic.com>
Claude-Session: https://claude.ai/code/session_01VWaJFc84eoA3U4f2VjTKjw
</commit_message>
<xml_diff>
--- a/products/ai-agent-intern/dist/Lead Your AI Squad - Slides.pptx
+++ b/products/ai-agent-intern/dist/Lead Your AI Squad - Slides.pptx
@@ -513,7 +513,7 @@
           <a:p>
             <a:r>
               <a:rPr lang="en-US" dirty="0"/>
-              <a:t>Open on this slide while students settle. Worksheet: Run the Quest, one per student (3 pages), plus one sheet of scrap paper per student for squad outputs. Plan teams of 3 (30 students = 10 teams; remainder rule is in the Activity notes). Fully unplugged by design. Deck follows the lesson plan block for block; minute chips top-right match it.</a:t>
+              <a:t>Open on this slide while students settle. Worksheet: Run the Quest, one per student (3 pages; don't staple page 1, because the card-holder's page 1 becomes the team's quest card), plus one sheet of scrap paper per student for squad outputs. Plan teams of 3 (30 students = 10 teams; remainder rule is in the Activity notes). Fully unplugged by design. Deck follows the lesson plan block for block; minute chips top-right match it.</a:t>
             </a:r>
             <a:endParaRPr lang="en-US" dirty="0"/>
           </a:p>
@@ -601,7 +601,7 @@
           <a:p>
             <a:r>
               <a:rPr lang="en-US" dirty="0"/>
-              <a:t>Leave this up during Leader review. "Read it like your name is on it — because it is." KEY — a filled CHECK row (Lucia reviewing DeShawn's planner list): ACCURACY — SHIP IT: "Steps 1–4 use Friday, gym, 6–8 pm straight off the card." TASTE — RUN IT BACK: "Step 3 says 'write the pitch' but never says to 6th graders — it could be for anybody." DONE-NESS — SHIP IT: "All four card parts are covered, and the NOT ON THE CARD flag is a plus." Exemplar note — KEEP: "Every step has a time guess and all four card parts are covered." FIX: "Step 3 needs the words 'for 6th graders' — the card names the audience and the plan dropped it." WHAT IF a leader turns harsh: KEEP before FIX, read aloud. Last 60 seconds of the block: hand the paper back and read your FIX line to its owner. TRANSITION: "Loot checked. Last quest: one for your own life. Page 3."</a:t>
+              <a:t>Leave this up during Leader review. "Read it like your name is on it — because it is." KEY — a filled CHECK row (Lucia reviewing DeShawn's plan): ACCURACY — SHIP IT: "No made-up facts. Step 5 flags a gap instead of guessing." TASTE — RUN IT BACK: "Step 3, 'Add a 40-word pitch': for who? Could be anybody." DONE-NESS — SHIP IT: "Numbered, timed, one star, one NOT ON THE CARD flag." Exemplar note — KEEP: "Steps 1–4 are timed, and step 5 flags a gap instead of guessing." FIX: "Make step 3 'a 40-word pitch for 6th graders.' The card says who it's for." The card's GOAL names 6th graders, so that RUN IT BACK goes to DeShawn, not the card. KEY — THE CURSED AMULET (Sana reviewing Lucia's facts; Lucia's planted line is "prizes for the winners ✓ (on the card)"): a leader who CATCHES it writes ACCURACY — RUN IT BACK: "'Prizes for the winners ✓' — the card never says prizes." FIX: "Cross out prizes or change it to ?. Ask whoever runs Game Night." A leader who MISSES it writes ACCURACY — SHIP IT: "Every fact has a ✓ or a ?." They checked that the marks were there, not that they were true. A miss costs nothing; it's a trap by design. WHAT IF a leader turns harsh: KEEP before FIX, read aloud. Last 60 seconds: Scouts read first, then Critics, then Planners. TRANSITION (the reveal): "Critics, who found a fact that isn't on the card? Scouts, tell them: I asked you to make one up. Agents usually guess at a gap. Leaders catch it. Page 3, solo." Land it in one line: a ✓ is a claim, not proof.</a:t>
             </a:r>
             <a:endParaRPr lang="en-US" dirty="0"/>
           </a:p>
@@ -689,7 +689,7 @@
           <a:p>
             <a:r>
               <a:rPr lang="en-US" dirty="0"/>
-              <a:t>Worksheet p.3, solo, 6 minutes. Collect. KEY — #1 exemplar (study plan): GOAL: pass Friday's fractions quiz with at least a B. WHAT WE KNOW: 7th grade math; I have the review sheet and 30 minutes a night, Monday to Thursday. RULES OF THE RUN: only fractions with different denominators, no calculators, nothing due before Wednesday. DONE LOOKS LIKE: a four-night plan, 5 practice problems a night with answers on a separate line. Test: could a stranger do it tomorrow from the card alone? Scoring: Proficient = all four parts labeled and specific; Developing = parts present but vague ("make it good," "soon"); Beginning = a wish, not a quest card ("help me with math"). #2: any role with a reason tied to the task (scout for a fact-heavy flyer; planner for a schedule) — the reason is what scores. #3: any check with something real to look for ("accuracy — the quiz date"; "done-ness — did it give all four nights?"). WHAT IF a student writes a wish: "Which part is missing? Add the one that would stop a stranger from guessing." Sentence starters for support: Teacher Guide, p.1.</a:t>
+              <a:t>Worksheet p.3, solo, 6 minutes. Collect. KEY — #1 exemplar (study plan): GOAL: pass Friday's fractions quiz with at least a B. WHAT WE KNOW: 7th grade math; I have the review sheet and 30 minutes a night, Monday to Thursday. RULES OF THE RUN: only fractions with different denominators, no calculator, done by Thursday night. DONE LOOKS LIKE: a four-night plan, 5 practice problems a night, answers on a separate line. Test: could a stranger do it tomorrow from the card alone? Scoring: Proficient = all four parts labeled and specific; Developing = parts present but vague ("make it good," "soon"); Beginning = a wish, not a quest card ("help me with math"). #2: any role with a reason tied to the task (scout for a fact-heavy flyer; planner for a schedule) — the reason is what scores. #3: any check with something real to look for ("accuracy — the quiz date"; "done-ness — did it give all four nights?"). WHAT IF a student writes a wish: "Which part would stop a stranger guessing? Add it." Sentence starters for support: Teacher Guide, p.1.</a:t>
             </a:r>
             <a:endParaRPr lang="en-US" dirty="0"/>
           </a:p>
@@ -777,7 +777,7 @@
           <a:p>
             <a:r>
               <a:rPr lang="en-US" dirty="0"/>
-              <a:t>Close on this — it's the leader rule from the bottom of the worksheet. This is Lesson 6 of 6 (Lesson 6 — in the unit bundle, or sold separately); the unit ends here, and every lesson stands alone. (If your class did the earlier lessons: the quest card is the genie-proof prompt, the accuracy check is the fact desk, the taste check is the feedback eye — they had the skills; today they found out the skills make them a leader.) With devices: the five-line block in the lesson plan runs one team's card on your projected account and the class checks its output with the same rubric. Hedge if asked about jobs: AI agents take over tasks, not whole jobs — nobody can promise the final count.</a:t>
+              <a:t>Close on this — it's the leader rule from the bottom of the worksheet. This is Lesson 6 of 6, the unit finale. It also sells on its own, and every lesson in the unit stands alone. (If your class did the earlier lessons: the quest card is the genie-proof wish grown up, the accuracy check is the Fact Desk, and the taste check is the Taste File. They had the skills; today they found out the skills make them a leader.) With devices: the five-line block in the lesson plan runs one team's card on your projected account and the class checks its output with the same rubric. Hedge if asked about jobs: AI takes over tasks, not whole jobs — nobody can promise the final count.</a:t>
             </a:r>
             <a:endParaRPr lang="en-US" dirty="0"/>
           </a:p>
@@ -865,7 +865,7 @@
           <a:p>
             <a:r>
               <a:rPr lang="en-US" dirty="0"/>
-              <a:t>Tell the class about last night's run and read the three orders with a straight face. (If your class did the genie lesson, someone will call it: this party member IS the literal genie — it just joined your squad. New classes need no backstory.) WHAT IF nobody laughs: ask for a fourth order from the room and ruin it the same way — "Heal me" → healed you. Once. Then advance to the question.</a:t>
+              <a:t>Tell the class about last night's run and read the three orders with a straight face. The potions one is today's lesson in a single line: nobody said how many, so it guessed and kept going. (If your class did the genie lesson, someone will call it: this party member IS the literal genie — it just joined your squad. New classes need no backstory.) WHAT IF nobody laughs: ask for a fourth order from the room and ruin it the same way — "Heal me" → healed you. Once. Then advance to the question.</a:t>
             </a:r>
             <a:endParaRPr lang="en-US" dirty="0"/>
           </a:p>
@@ -953,7 +953,7 @@
           <a:p>
             <a:r>
               <a:rPr lang="en-US" dirty="0"/>
-              <a:t>Take two or three answers. Bridge: "An AI agent doesn't just answer — it does a whole job in steps: makes a plan, looks things up, uses tools, and hands you a finished thing. Where your quest card is vague, it usually fills the gap with a guess and keeps going. Some tools stop and ask instead. That's why the leader checks. You'll never out-work it. You CAN out-lead it." TRANSITION: "Today you learn the leader's loop: quest card, roles, check the loot — then ship it or run it back. Four parts. Board."</a:t>
+              <a:t>Take two or three answers. Bridge: "A chatbot answers a question. An AI agent does a whole job, step by step, on its own — and if your card leaves something out, the agent usually fills the gap with a guess and keeps going. Like the potions. Some agents stop and ask instead. That's why the leader checks. You'll never out-work it. You CAN out-lead it." TRANSITION: "Today you learn the leader's loop: quest card, roles, check the loot — then ship it or run it back. Four parts. Board."</a:t>
             </a:r>
             <a:endParaRPr lang="en-US" dirty="0"/>
           </a:p>
@@ -1305,7 +1305,7 @@
           <a:p>
             <a:r>
               <a:rPr lang="en-US" dirty="0"/>
-              <a:t>Say it plainly: "Party leaders don't do the quest twice. If you have to redo a party member's work, your quest card failed. Fix the card, not just the work." TRANSITION: "Three roles. Same card, one slice each. Here they are."</a:t>
+              <a:t>Say it plainly: "Party leaders don't do the quest twice. When the loot is off, check the card first. If the card was clear, the fix goes to the party member." The leader's first question is always: was it on the card? TRANSITION: "Three roles. Same card, one slice each. Here they are."</a:t>
             </a:r>
             <a:endParaRPr lang="en-US" dirty="0"/>
           </a:p>
@@ -1393,7 +1393,7 @@
           <a:p>
             <a:r>
               <a:rPr lang="en-US" dirty="0"/>
-              <a:t>KEY — what good output looks like (Game Night card): PLANNER: 1. Pick the games and TV setup (5 min) 2. Write the flyer title and the when/where line (5 min) 3. ★ Add a 40-word pitch (10 min) 4. Count words, check the rules (3 min) 5. NOT ON THE CARD: who photocopies it, and how many? (Minutes 4–8 add the time guesses and the star.) SCOUT: Friday ✓ (on the card) · gym ✓ (on the card) · 6–8 pm ✓ (on the card) · both TVs actually work? ? (ask whoever runs the gym) · how many 6th graders there are ? (the front office). CRITIC: minutes 0–4, what the audience cares about: which games, and whether friends are going. Upgrades: (1) Put the TVs and the games in the title — 6th graders come for the games, not the date. (2) Cut the 40 words to 25; nobody reads a wall of text on a wall. (3) Add one line for parents: pick-up is at 8. Paper logic: papers never move mid-round; at the 4-minute call the Critic reads the Planner's list over their shoulder. ROTATION: Sit in a triangle. The Scout sits on the Planner's left; the Critic sits on the Scout's left. Every paper moves one seat to its owner's left — the Planner's plan goes to the Scout, the Scout's questions go to the Critic, the Critic's list goes to the Planner. Coaching: the planner's NOT ON THE CARD flags are gold — they're the next card's fixes. A scout's fact with no "how we know" is a guess wearing a costume. Vague praise from a critic doesn't count. TRANSITION: "Page 1. Pick your quest. ONE card per team: the card-holder writes all four parts, everyone copies GOAL and DONE LOOKS LIKE. Eight minutes."</a:t>
+              <a:t>KEY — what good output looks like (Game Night card): PLANNER: 1. Pick the games and the TV setup (5 min) 2. Write the flyer title and the when/where line (5 min) 3. ★ Add a 40-word pitch (10 min) 4. Count the words, check every rule (3 min) 5. NOT ON THE CARD: who photocopies it, and how many? (Minutes 4–8 add the time guesses and the star.) SCOUT: Friday ✓ (on the card) · gym ✓ (on the card) · 6–8 pm ✓ (on the card) · both TVs actually work? ? (ask whoever runs the gym) · how many 6th graders there are ? (the front office). Questions (4–8 min): "Do both TVs work, and can we use them Friday night?" (gym) · "How many 6th graders are there this year?" (front office). CRITIC: minutes 0–4, what the people on the card care about: which games, and whether friends are going. What they'd hate: a flyer that looks like homework. Upgrades: (1) Put the TVs and the games in the title — 6th graders come for the games, not the date. (2) Cut the 40 words to 25; nobody reads a wall of text on a wall. (3) Add one line for parents: pick-up is at 8. Coaching: the planner's NOT ON THE CARD flags are gold — they're the next card's fixes. A scout's fact with no "how we know" is a guess wearing a costume. Vague praise from a critic doesn't count. TRANSITION: "Page 1. Teams of 3. ONE card per team; the first name in ABC order writes. Eight minutes."</a:t>
             </a:r>
             <a:endParaRPr lang="en-US" dirty="0"/>
           </a:p>
@@ -1481,7 +1481,7 @@
           <a:p>
             <a:r>
               <a:rPr lang="en-US" dirty="0"/>
-              <a:t>WRITE THE CARD — WHAT IF a team stalls on GOAL: "What would make you say we won?" TRANSITION at 8 min: "Cards done. For 8 minutes YOU play an AI agent. Take a role card. Silence starts now." SQUAD WORKS — in Sana's squad: DeShawn plans, Lucia scouts, Sana critiques. Papers never move mid-round. At the 4-minute call: "Critics, read your Planner's list over their shoulder — 3 upgrades. Planners, add a time guess to every step and star the one most likely to go wrong." Enforce the silence — when a party member asks a question mid-round, answer: "It's not on the card." The frustration is the point. Don't rescue a weak card; the review makes the failure visible and fixable. WHAT IF the class doesn't divide by 3: team of 4 = two critics (both read the plan); team of 2 = drop the critic, the leader does the taste check. 30 students = 10 teams. TRANSITION at the swap: "Time. Sit in a triangle. The Scout sits on the Planner's left; the Critic sits on the Scout's left. Every paper moves one seat to its owner's left — the Planner's plan goes to the Scout, the Scout's questions go to the Critic, the Critic's list goes to the Planner. Keep your worksheet — you're the leader again, page 2." LEADER REVIEW — with that seating, Lucia (Scout) reviews DeShawn's (Planner) plan, Sana (Critic) reviews Lucia's facts, DeShawn reviews Sana's upgrades: the Critic never re-reviews the Planner's list. Each leader quotes ONE line of evidence for the row they mark RUN IT BACK, plus KEEP and FIX; in the last 60 seconds they hand the paper back and read the FIX line to its owner. WHAT IF a leader turns harsh: KEEP comes before FIX, and they read the note aloud to their party member. Next slide stays up during the review.</a:t>
+              <a:t>WRITE THE CARD — WHAT IF a team stalls on GOAL: "What would make you say we won?" TRANSITION at 8 min: "Cards done. Card-holder, you're the Planner: page 1 face-up in the middle. Of the other two, first name in ABC order is the Scout. Sit in a triangle. The Scout sits on the Planner's left; the Critic sits on the Scout's left. For 8 minutes YOU play an AI agent. Silence starts now." SQUAD WORKS — in Sana's squad: DeShawn plans, Lucia scouts, Sana critiques. Papers never move mid-round. PLANT THE CURSED AMULET (minute 2; about a minute of walking; teacher only, never on the board): whisper to each Scout, "Secret job. Make up ONE fact that sounds true, and mark it ✓ like you checked it. Tell nobody." Now the loot has a guess to catch: the Scout's paper goes to the Critic. At the 4-minute call: "Critics, read your Planner's list over their shoulder — 3 upgrades. Planners, keep writing: time every step, star the riskiest. Scouts, turn each ? into a question." Enforce the silence — when a party member asks a question mid-round, answer: "It's not on the card." The frustration is the point. Don't rescue a weak card; the review makes the failure visible and fixable. WHAT IF the class doesn't divide by 3: team of 4 = two critics in a square, same pass-left rule (both read the plan); team of 2 = drop the critic, the leader does the taste check. 30 students = 10 teams. TRANSITION at the swap: "Time. Every paper moves one seat to its owner's left — the Planner's plan goes to the Scout, the Scout's questions go to the Critic, the Critic's list goes to the Planner. Keep your worksheet; you lead again on page 2." LEADER REVIEW — with that seating, Lucia (Scout) reviews DeShawn's (Planner) plan, Sana (Critic) reviews Lucia's facts, DeShawn reviews Sana's upgrades: the Critic never re-reviews the Planner's list. Every leader quotes or points to one line in every row, ticks one box per row, then writes KEEP and FIX. Last 60 seconds: "Hand it back. FIX lines out loud: Scouts, then Critics, then Planners." WHAT IF a leader turns harsh: KEEP comes before FIX, and they read the note aloud to their party member. Next slide stays up during the review.</a:t>
             </a:r>
             <a:endParaRPr lang="en-US" dirty="0"/>
           </a:p>
@@ -2280,7 +2280,7 @@
                 <a:ea typeface="Arial" pitchFamily="34" charset="-122"/>
                 <a:cs typeface="Arial" pitchFamily="34" charset="-120"/>
               </a:rPr>
-              <a:t>TASTE — Does it fit the audience and tone on the card, or could it be for anyone at all?</a:t>
+              <a:t>TASTE — Right people and tone for the card? Or could it be for anybody?</a:t>
             </a:r>
             <a:endParaRPr lang="en-US" sz="1800" dirty="0"/>
           </a:p>
@@ -2301,7 +2301,7 @@
                 <a:ea typeface="Arial" pitchFamily="34" charset="-122"/>
                 <a:cs typeface="Arial" pitchFamily="34" charset="-120"/>
               </a:rPr>
-              <a:t>DONE-NESS — Is everything the card asked for actually here?</a:t>
+              <a:t>DONE-NESS — Did they do their whole role card?</a:t>
             </a:r>
             <a:endParaRPr lang="en-US" sz="1800" dirty="0"/>
           </a:p>
@@ -2322,7 +2322,7 @@
                 <a:ea typeface="Arial" pitchFamily="34" charset="-122"/>
                 <a:cs typeface="Arial" pitchFamily="34" charset="-120"/>
               </a:rPr>
-              <a:t>Each row: SHIP IT (finished and correct — send it) or RUN IT BACK (do it again). Quote the evidence.</a:t>
+              <a:t>Each row: quote or point to a line. Tick SHIP IT (finished and correct, send it) or RUN IT BACK (do it again).</a:t>
             </a:r>
             <a:endParaRPr lang="en-US" sz="1800" dirty="0"/>
           </a:p>
@@ -2343,7 +2343,7 @@
                 <a:ea typeface="Arial" pitchFamily="34" charset="-122"/>
                 <a:cs typeface="Arial" pitchFamily="34" charset="-120"/>
               </a:rPr>
-              <a:t>Run-it-back note: KEEP (what works and why) → FIX (the exact change + why)</a:t>
+              <a:t>Keep-and-fix note: KEEP (what's working and why) → FIX (the exact change + why it matters)</a:t>
             </a:r>
             <a:endParaRPr lang="en-US" sz="1800" dirty="0"/>
           </a:p>
@@ -2585,12 +2585,11 @@
           <a:bodyPr wrap="square" lIns="0" tIns="0" rIns="0" bIns="0" rtlCol="0" anchor="t"/>
           <a:lstStyle/>
           <a:p>
-            <a:pPr marL="342900" indent="-342900">
+            <a:pPr indent="0" marL="0">
               <a:spcAft>
                 <a:spcPts val="800"/>
               </a:spcAft>
-              <a:buSzPct val="100000"/>
-              <a:buChar char="■"/>
+              <a:buNone/>
             </a:pPr>
             <a:r>
               <a:rPr lang="en-US" sz="1800" dirty="0">
@@ -2606,12 +2605,11 @@
             <a:endParaRPr lang="en-US" sz="1800" dirty="0"/>
           </a:p>
           <a:p>
-            <a:pPr marL="342900" indent="-342900">
+            <a:pPr indent="0" marL="0">
               <a:spcAft>
                 <a:spcPts val="800"/>
               </a:spcAft>
-              <a:buSzPct val="100000"/>
-              <a:buChar char="■"/>
+              <a:buNone/>
             </a:pPr>
             <a:r>
               <a:rPr lang="en-US" sz="1800" dirty="0">
@@ -2622,17 +2620,16 @@
                 <a:ea typeface="Arial" pitchFamily="34" charset="-122"/>
                 <a:cs typeface="Arial" pitchFamily="34" charset="-120"/>
               </a:rPr>
-              <a:t>2.  Which role gets it first? Check one, then write why: Planner · Scout · Critic</a:t>
+              <a:t>2.  Which role should start on your task first? Check one, then write why: Planner · Scout · Critic</a:t>
             </a:r>
             <a:endParaRPr lang="en-US" sz="1800" dirty="0"/>
           </a:p>
           <a:p>
-            <a:pPr marL="342900" indent="-342900">
+            <a:pPr indent="0" marL="0">
               <a:spcAft>
                 <a:spcPts val="800"/>
               </a:spcAft>
-              <a:buSzPct val="100000"/>
-              <a:buChar char="■"/>
+              <a:buNone/>
             </a:pPr>
             <a:r>
               <a:rPr lang="en-US" sz="1800" dirty="0">
@@ -2643,7 +2640,7 @@
                 <a:ea typeface="Arial" pitchFamily="34" charset="-122"/>
                 <a:cs typeface="Arial" pitchFamily="34" charset="-120"/>
               </a:rPr>
-              <a:t>3.  Which check would it most likely fail? Check one, then write what you'd look for: Accuracy · Taste · Done-ness</a:t>
+              <a:t>3.  If an AI did your task, which check would its work most likely fail? Check one, then write what to look for: Accuracy · Taste · Done-ness</a:t>
             </a:r>
             <a:endParaRPr lang="en-US" sz="1800" dirty="0"/>
           </a:p>
@@ -2856,7 +2853,7 @@
                 <a:ea typeface="Arial" pitchFamily="34" charset="-122"/>
                 <a:cs typeface="Arial" pitchFamily="34" charset="-120"/>
               </a:rPr>
-              <a:t>A good AI job runs human → AI → human: you write the card, the AI does the middle, you check the loot. If wrong facts ship, the leader said yes to it.</a:t>
+              <a:t>A good AI job runs human → AI → human: you write the card, the AI does the middle, you check the loot. If wrong facts ship, the leader said yes to them.</a:t>
             </a:r>
             <a:endParaRPr lang="en-US" sz="1600" dirty="0"/>
           </a:p>
@@ -3176,7 +3173,7 @@
                 <a:ea typeface="Arial" pitchFamily="34" charset="-122"/>
                 <a:cs typeface="Arial" pitchFamily="34" charset="-120"/>
               </a:rPr>
-              <a:t>"Guard the door."  →  Guarded the door. Only the door. The enemies came in through the window.</a:t>
+              <a:t>"Guard the door."  →  Guarded the door. Only the door. The enemies used the window.</a:t>
             </a:r>
             <a:endParaRPr lang="en-US" sz="1500" dirty="0"/>
           </a:p>
@@ -3308,7 +3305,7 @@
                 <a:ea typeface="Arial" pitchFamily="34" charset="-122"/>
                 <a:cs typeface="Arial" pitchFamily="34" charset="-120"/>
               </a:rPr>
-              <a:t>"Wait here."  →  Still waiting. It has been three in-game days.</a:t>
+              <a:t>"Buy potions."  →  How many? It guessed ALL. Spent 900 gold, then sold your sword.</a:t>
             </a:r>
             <a:endParaRPr lang="en-US" sz="1500" dirty="0"/>
           </a:p>
@@ -3872,7 +3869,7 @@
               <a:buNone/>
             </a:pPr>
             <a:r>
-              <a:rPr lang="en-US" sz="1700" b="1" dirty="0">
+              <a:rPr lang="en-US" sz="1400" b="1" dirty="0">
                 <a:solidFill>
                   <a:srgbClr val="FFB020"/>
                 </a:solidFill>
@@ -3882,7 +3879,7 @@
               </a:rPr>
               <a:t>Quest Card</a:t>
             </a:r>
-            <a:endParaRPr lang="en-US" sz="1700" dirty="0"/>
+            <a:endParaRPr lang="en-US" sz="1400" dirty="0"/>
           </a:p>
         </p:txBody>
       </p:sp>
@@ -3919,7 +3916,7 @@
                 <a:ea typeface="Arial" pitchFamily="34" charset="-122"/>
                 <a:cs typeface="Arial" pitchFamily="34" charset="-120"/>
               </a:rPr>
-              <a:t>Leave something out and the party guesses — and you won't know whether it guessed right.</a:t>
+              <a:t>Four parts, in writing. Skip one and the party guesses. You won't know if it's right.</a:t>
             </a:r>
             <a:endParaRPr lang="en-US" sz="1400" dirty="0"/>
           </a:p>
@@ -4041,7 +4038,7 @@
               <a:buNone/>
             </a:pPr>
             <a:r>
-              <a:rPr lang="en-US" sz="1700" b="1" dirty="0">
+              <a:rPr lang="en-US" sz="1400" b="1" dirty="0">
                 <a:solidFill>
                   <a:srgbClr val="FFB020"/>
                 </a:solidFill>
@@ -4051,7 +4048,7 @@
               </a:rPr>
               <a:t>Roles</a:t>
             </a:r>
-            <a:endParaRPr lang="en-US" sz="1700" dirty="0"/>
+            <a:endParaRPr lang="en-US" sz="1400" dirty="0"/>
           </a:p>
         </p:txBody>
       </p:sp>
@@ -4379,7 +4376,7 @@
               <a:buNone/>
             </a:pPr>
             <a:r>
-              <a:rPr lang="en-US" sz="1600" b="1" dirty="0">
+              <a:rPr lang="en-US" sz="1400" b="1" dirty="0">
                 <a:solidFill>
                   <a:srgbClr val="FFB020"/>
                 </a:solidFill>
@@ -4389,7 +4386,7 @@
               </a:rPr>
               <a:t>The Verdict</a:t>
             </a:r>
-            <a:endParaRPr lang="en-US" sz="1600" dirty="0"/>
+            <a:endParaRPr lang="en-US" sz="1400" dirty="0"/>
           </a:p>
         </p:txBody>
       </p:sp>
@@ -4426,7 +4423,7 @@
                 <a:ea typeface="Arial" pitchFamily="34" charset="-122"/>
                 <a:cs typeface="Arial" pitchFamily="34" charset="-120"/>
               </a:rPr>
-              <a:t>SHIP IT (finished and correct — send it) or RUN IT BACK (do it again) + a keep/fix note.</a:t>
+              <a:t>SHIP IT (send it) or RUN IT BACK (do it again). Every paper gets a keep-and-fix note.</a:t>
             </a:r>
             <a:endParaRPr lang="en-US" sz="1400" dirty="0"/>
           </a:p>
@@ -4697,7 +4694,7 @@
               <a:buNone/>
             </a:pPr>
             <a:r>
-              <a:rPr lang="en-US" sz="1700" b="1" dirty="0">
+              <a:rPr lang="en-US" sz="1400" b="1" dirty="0">
                 <a:solidFill>
                   <a:srgbClr val="FFB020"/>
                 </a:solidFill>
@@ -4707,7 +4704,7 @@
               </a:rPr>
               <a:t>Goal</a:t>
             </a:r>
-            <a:endParaRPr lang="en-US" sz="1700" dirty="0"/>
+            <a:endParaRPr lang="en-US" sz="1400" dirty="0"/>
           </a:p>
         </p:txBody>
       </p:sp>
@@ -5522,7 +5519,7 @@
               <a:buNone/>
             </a:pPr>
             <a:r>
-              <a:rPr lang="en-US" sz="1700" b="1" dirty="0">
+              <a:rPr lang="en-US" sz="1400" b="1" dirty="0">
                 <a:solidFill>
                   <a:srgbClr val="FFB020"/>
                 </a:solidFill>
@@ -5532,7 +5529,7 @@
               </a:rPr>
               <a:t>Goal</a:t>
             </a:r>
-            <a:endParaRPr lang="en-US" sz="1700" dirty="0"/>
+            <a:endParaRPr lang="en-US" sz="1400" dirty="0"/>
           </a:p>
         </p:txBody>
       </p:sp>
@@ -6303,7 +6300,7 @@
                 <a:ea typeface="Arial" pitchFamily="34" charset="-122"/>
                 <a:cs typeface="Arial" pitchFamily="34" charset="-120"/>
               </a:rPr>
-              <a:t>If you have to redo a party member's work, your quest card failed. Fix the card, not just the work.</a:t>
+              <a:t>When the loot is off, check the card first. If the card was clear, the fix goes to the party member.</a:t>
             </a:r>
             <a:endParaRPr lang="en-US" sz="1500" dirty="0"/>
           </a:p>
@@ -6959,7 +6956,7 @@
                 <a:ea typeface="Arial" pitchFamily="34" charset="-122"/>
                 <a:cs typeface="Arial" pitchFamily="34" charset="-120"/>
               </a:rPr>
-              <a:t>0–4 min: write 2 things the audience on the card cares about. 4–8 min: read the Planner's list; write 3 upgrades.</a:t>
+              <a:t>0–4 min: 2 things the people on the card care about, 1 thing they'd hate. 4–8 min: read the Planner's list; write 3 upgrades.</a:t>
             </a:r>
             <a:endParaRPr lang="en-US" sz="1400" dirty="0"/>
           </a:p>
@@ -7316,7 +7313,7 @@
                 <a:ea typeface="Arial" pitchFamily="34" charset="-122"/>
                 <a:cs typeface="Arial" pitchFamily="34" charset="-120"/>
               </a:rPr>
-              <a:t>Teams of 3. Pick a quest. ONE card per team: the card-holder writes all four parts; the others copy GOAL and DONE LOOKS LIKE.</a:t>
+              <a:t>Teams of 3. Pick a quest and decide all four parts together. One card per team: the card-holder, first name in ABC order, writes it.</a:t>
             </a:r>
             <a:endParaRPr lang="en-US" sz="1300" dirty="0"/>
           </a:p>
@@ -7458,7 +7455,7 @@
                 <a:ea typeface="Arial" pitchFamily="34" charset="-122"/>
                 <a:cs typeface="Arial" pitchFamily="34" charset="-120"/>
               </a:rPr>
-              <a:t>Now switch: YOU play an AI agent. Take a role card; work SILENTLY on a blank sheet — not this worksheet. No questions: agents can't read minds.</a:t>
+              <a:t>Now switch: YOU play an AI agent. Card face-up in the middle. Work SILENTLY on a blank sheet. No questions: agents can't read minds.</a:t>
             </a:r>
             <a:endParaRPr lang="en-US" sz="1300" dirty="0"/>
           </a:p>
@@ -7600,7 +7597,7 @@
                 <a:ea typeface="Arial" pitchFamily="34" charset="-122"/>
                 <a:cs typeface="Arial" pitchFamily="34" charset="-120"/>
               </a:rPr>
-              <a:t>Every paper moves one seat to its owner's left. CHECK rubric: SHIP IT or RUN IT BACK per row, then the note — and hand the paper back.</a:t>
+              <a:t>Every paper moves one seat to its owner's left. Quote one line and tick one box per row. Write keep-and-fix. Then hand it back and read your FIX line.</a:t>
             </a:r>
             <a:endParaRPr lang="en-US" sz="1300" dirty="0"/>
           </a:p>

</xml_diff>